<commit_message>
Presentation and readme.md update
</commit_message>
<xml_diff>
--- a/Market_analysis/docs/presentation.pptx
+++ b/Market_analysis/docs/presentation.pptx
@@ -5,7 +5,7 @@
     <p:sldMasterId id="2147483648" r:id="rId1"/>
   </p:sldMasterIdLst>
   <p:notesMasterIdLst>
-    <p:notesMasterId r:id="rId9"/>
+    <p:notesMasterId r:id="rId10"/>
   </p:notesMasterIdLst>
   <p:sldIdLst>
     <p:sldId id="256" r:id="rId2"/>
@@ -14,7 +14,8 @@
     <p:sldId id="259" r:id="rId5"/>
     <p:sldId id="260" r:id="rId6"/>
     <p:sldId id="261" r:id="rId7"/>
-    <p:sldId id="263" r:id="rId8"/>
+    <p:sldId id="264" r:id="rId8"/>
+    <p:sldId id="263" r:id="rId9"/>
   </p:sldIdLst>
   <p:sldSz cx="12192000" cy="6858000"/>
   <p:notesSz cx="6858000" cy="9144000"/>
@@ -113,6 +114,11 @@
       </a:defRPr>
     </a:lvl9pPr>
   </p:defaultTextStyle>
+  <p:extLst>
+    <p:ext uri="{EFAFB233-063F-42B5-8137-9DF3F51BA10A}">
+      <p15:sldGuideLst xmlns:p15="http://schemas.microsoft.com/office/powerpoint/2012/main"/>
+    </p:ext>
+  </p:extLst>
 </p:presentation>
 </file>
 
@@ -977,6 +983,114 @@
     <p:extLst>
       <p:ext uri="{BB962C8B-B14F-4D97-AF65-F5344CB8AC3E}">
         <p14:creationId xmlns:p14="http://schemas.microsoft.com/office/powerpoint/2010/main" val="148141490"/>
+      </p:ext>
+    </p:extLst>
+  </p:cSld>
+  <p:clrMapOvr>
+    <a:masterClrMapping/>
+  </p:clrMapOvr>
+</p:notes>
+</file>
+
+<file path=ppt/notesSlides/notesSlide5.xml><?xml version="1.0" encoding="utf-8"?>
+<p:notes xmlns:a="http://schemas.openxmlformats.org/drawingml/2006/main" xmlns:r="http://schemas.openxmlformats.org/officeDocument/2006/relationships" xmlns:p="http://schemas.openxmlformats.org/presentationml/2006/main">
+  <p:cSld>
+    <p:spTree>
+      <p:nvGrpSpPr>
+        <p:cNvPr id="1" name="">
+          <a:extLst>
+            <a:ext uri="{FF2B5EF4-FFF2-40B4-BE49-F238E27FC236}">
+              <a16:creationId xmlns:a16="http://schemas.microsoft.com/office/drawing/2014/main" id="{E902EBA0-8622-33BA-75CC-01BBCB24BB54}"/>
+            </a:ext>
+          </a:extLst>
+        </p:cNvPr>
+        <p:cNvGrpSpPr/>
+        <p:nvPr/>
+      </p:nvGrpSpPr>
+      <p:grpSpPr>
+        <a:xfrm>
+          <a:off x="0" y="0"/>
+          <a:ext cx="0" cy="0"/>
+          <a:chOff x="0" y="0"/>
+          <a:chExt cx="0" cy="0"/>
+        </a:xfrm>
+      </p:grpSpPr>
+      <p:sp>
+        <p:nvSpPr>
+          <p:cNvPr id="2" name="Slide Image Placeholder 1">
+            <a:extLst>
+              <a:ext uri="{FF2B5EF4-FFF2-40B4-BE49-F238E27FC236}">
+                <a16:creationId xmlns:a16="http://schemas.microsoft.com/office/drawing/2014/main" id="{FC085616-EC33-FB88-A4EE-C801F55DF1F1}"/>
+              </a:ext>
+            </a:extLst>
+          </p:cNvPr>
+          <p:cNvSpPr>
+            <a:spLocks noGrp="1" noRot="1" noChangeAspect="1"/>
+          </p:cNvSpPr>
+          <p:nvPr>
+            <p:ph type="sldImg"/>
+          </p:nvPr>
+        </p:nvSpPr>
+        <p:spPr/>
+      </p:sp>
+      <p:sp>
+        <p:nvSpPr>
+          <p:cNvPr id="3" name="Notes Placeholder 2">
+            <a:extLst>
+              <a:ext uri="{FF2B5EF4-FFF2-40B4-BE49-F238E27FC236}">
+                <a16:creationId xmlns:a16="http://schemas.microsoft.com/office/drawing/2014/main" id="{629AF382-EF6D-5B38-45D0-35AC41EA7318}"/>
+              </a:ext>
+            </a:extLst>
+          </p:cNvPr>
+          <p:cNvSpPr>
+            <a:spLocks noGrp="1"/>
+          </p:cNvSpPr>
+          <p:nvPr>
+            <p:ph type="body" idx="1"/>
+          </p:nvPr>
+        </p:nvSpPr>
+        <p:spPr/>
+        <p:txBody>
+          <a:bodyPr/>
+          <a:lstStyle/>
+          <a:p>
+            <a:endParaRPr lang="en-US" dirty="0"/>
+          </a:p>
+        </p:txBody>
+      </p:sp>
+      <p:sp>
+        <p:nvSpPr>
+          <p:cNvPr id="4" name="Slide Number Placeholder 3">
+            <a:extLst>
+              <a:ext uri="{FF2B5EF4-FFF2-40B4-BE49-F238E27FC236}">
+                <a16:creationId xmlns:a16="http://schemas.microsoft.com/office/drawing/2014/main" id="{21582913-2A0F-7DE9-DA12-F785296940E2}"/>
+              </a:ext>
+            </a:extLst>
+          </p:cNvPr>
+          <p:cNvSpPr>
+            <a:spLocks noGrp="1"/>
+          </p:cNvSpPr>
+          <p:nvPr>
+            <p:ph type="sldNum" sz="quarter" idx="5"/>
+          </p:nvPr>
+        </p:nvSpPr>
+        <p:spPr/>
+        <p:txBody>
+          <a:bodyPr/>
+          <a:lstStyle/>
+          <a:p>
+            <a:fld id="{B57480FD-7D86-1642-A036-0DEAB8E504FA}" type="slidenum">
+              <a:rPr lang="en-US" smtClean="0"/>
+              <a:t>7</a:t>
+            </a:fld>
+            <a:endParaRPr lang="en-US"/>
+          </a:p>
+        </p:txBody>
+      </p:sp>
+    </p:spTree>
+    <p:extLst>
+      <p:ext uri="{BB962C8B-B14F-4D97-AF65-F5344CB8AC3E}">
+        <p14:creationId xmlns:p14="http://schemas.microsoft.com/office/powerpoint/2010/main" val="1333128014"/>
       </p:ext>
     </p:extLst>
   </p:cSld>
@@ -11016,6 +11130,352 @@
 </file>
 
 <file path=ppt/slides/slide7.xml><?xml version="1.0" encoding="utf-8"?>
+<p:sld xmlns:a="http://schemas.openxmlformats.org/drawingml/2006/main" xmlns:r="http://schemas.openxmlformats.org/officeDocument/2006/relationships" xmlns:p="http://schemas.openxmlformats.org/presentationml/2006/main">
+  <p:cSld>
+    <p:spTree>
+      <p:nvGrpSpPr>
+        <p:cNvPr id="1" name="">
+          <a:extLst>
+            <a:ext uri="{FF2B5EF4-FFF2-40B4-BE49-F238E27FC236}">
+              <a16:creationId xmlns:a16="http://schemas.microsoft.com/office/drawing/2014/main" id="{0329C1B2-8A3F-A098-9458-67039E2D36AF}"/>
+            </a:ext>
+          </a:extLst>
+        </p:cNvPr>
+        <p:cNvGrpSpPr/>
+        <p:nvPr/>
+      </p:nvGrpSpPr>
+      <p:grpSpPr>
+        <a:xfrm>
+          <a:off x="0" y="0"/>
+          <a:ext cx="0" cy="0"/>
+          <a:chOff x="0" y="0"/>
+          <a:chExt cx="0" cy="0"/>
+        </a:xfrm>
+      </p:grpSpPr>
+      <p:sp>
+        <p:nvSpPr>
+          <p:cNvPr id="2" name="Title 1">
+            <a:extLst>
+              <a:ext uri="{FF2B5EF4-FFF2-40B4-BE49-F238E27FC236}">
+                <a16:creationId xmlns:a16="http://schemas.microsoft.com/office/drawing/2014/main" id="{3C9836A2-AA19-CEF9-0C42-99B4E5398847}"/>
+              </a:ext>
+            </a:extLst>
+          </p:cNvPr>
+          <p:cNvSpPr>
+            <a:spLocks noGrp="1"/>
+          </p:cNvSpPr>
+          <p:nvPr>
+            <p:ph type="title"/>
+          </p:nvPr>
+        </p:nvSpPr>
+        <p:spPr/>
+        <p:txBody>
+          <a:bodyPr/>
+          <a:lstStyle/>
+          <a:p>
+            <a:r>
+              <a:rPr lang="en-US" dirty="0"/>
+              <a:t>Running the App</a:t>
+            </a:r>
+          </a:p>
+        </p:txBody>
+      </p:sp>
+      <p:pic>
+        <p:nvPicPr>
+          <p:cNvPr id="6" name="Content Placeholder 5" descr="A screenshot of a computer&#10;&#10;AI-generated content may be incorrect.">
+            <a:extLst>
+              <a:ext uri="{FF2B5EF4-FFF2-40B4-BE49-F238E27FC236}">
+                <a16:creationId xmlns:a16="http://schemas.microsoft.com/office/drawing/2014/main" id="{716CF649-D902-F27B-357B-11A0477BF28F}"/>
+              </a:ext>
+            </a:extLst>
+          </p:cNvPr>
+          <p:cNvPicPr>
+            <a:picLocks noGrp="1" noChangeAspect="1"/>
+          </p:cNvPicPr>
+          <p:nvPr>
+            <p:ph idx="1"/>
+          </p:nvPr>
+        </p:nvPicPr>
+        <p:blipFill>
+          <a:blip r:embed="rId3"/>
+          <a:stretch>
+            <a:fillRect/>
+          </a:stretch>
+        </p:blipFill>
+        <p:spPr>
+          <a:xfrm>
+            <a:off x="2166890" y="1428465"/>
+            <a:ext cx="8404128" cy="5047150"/>
+          </a:xfrm>
+          <a:prstGeom prst="rect">
+            <a:avLst/>
+          </a:prstGeom>
+        </p:spPr>
+      </p:pic>
+      <p:sp>
+        <p:nvSpPr>
+          <p:cNvPr id="4" name="Content Placeholder 2">
+            <a:extLst>
+              <a:ext uri="{FF2B5EF4-FFF2-40B4-BE49-F238E27FC236}">
+                <a16:creationId xmlns:a16="http://schemas.microsoft.com/office/drawing/2014/main" id="{9E7DC39F-1DC8-F005-6511-8D765EE6C3E4}"/>
+              </a:ext>
+            </a:extLst>
+          </p:cNvPr>
+          <p:cNvSpPr txBox="1">
+            <a:spLocks/>
+          </p:cNvSpPr>
+          <p:nvPr/>
+        </p:nvSpPr>
+        <p:spPr>
+          <a:xfrm>
+            <a:off x="6606699" y="2286001"/>
+            <a:ext cx="5128101" cy="3593591"/>
+          </a:xfrm>
+          <a:prstGeom prst="rect">
+            <a:avLst/>
+          </a:prstGeom>
+        </p:spPr>
+        <p:txBody>
+          <a:bodyPr vert="horz" lIns="91440" tIns="45720" rIns="91440" bIns="45720" rtlCol="0">
+            <a:normAutofit/>
+          </a:bodyPr>
+          <a:lstStyle>
+            <a:lvl1pPr marL="228600" indent="-228600" algn="l" defTabSz="914400" rtl="0" eaLnBrk="1" latinLnBrk="0" hangingPunct="1">
+              <a:lnSpc>
+                <a:spcPct val="110000"/>
+              </a:lnSpc>
+              <a:spcBef>
+                <a:spcPts val="700"/>
+              </a:spcBef>
+              <a:buClr>
+                <a:schemeClr val="tx2"/>
+              </a:buClr>
+              <a:buFont typeface="Arial" panose="020B0604020202020204" pitchFamily="34" charset="0"/>
+              <a:buChar char="•"/>
+              <a:defRPr sz="2000" kern="1200">
+                <a:solidFill>
+                  <a:schemeClr val="tx1">
+                    <a:lumMod val="65000"/>
+                    <a:lumOff val="35000"/>
+                  </a:schemeClr>
+                </a:solidFill>
+                <a:latin typeface="+mn-lt"/>
+                <a:ea typeface="+mn-ea"/>
+                <a:cs typeface="+mn-cs"/>
+              </a:defRPr>
+            </a:lvl1pPr>
+            <a:lvl2pPr marL="685800" indent="-228600" algn="l" defTabSz="914400" rtl="0" eaLnBrk="1" latinLnBrk="0" hangingPunct="1">
+              <a:lnSpc>
+                <a:spcPct val="110000"/>
+              </a:lnSpc>
+              <a:spcBef>
+                <a:spcPts val="700"/>
+              </a:spcBef>
+              <a:buClr>
+                <a:schemeClr val="tx2"/>
+              </a:buClr>
+              <a:buFont typeface="Gill Sans MT" panose="020B0502020104020203" pitchFamily="34" charset="0"/>
+              <a:buChar char="–"/>
+              <a:defRPr sz="1800" kern="1200">
+                <a:solidFill>
+                  <a:schemeClr val="tx1">
+                    <a:lumMod val="65000"/>
+                    <a:lumOff val="35000"/>
+                  </a:schemeClr>
+                </a:solidFill>
+                <a:latin typeface="+mn-lt"/>
+                <a:ea typeface="+mn-ea"/>
+                <a:cs typeface="+mn-cs"/>
+              </a:defRPr>
+            </a:lvl2pPr>
+            <a:lvl3pPr marL="1143000" indent="-228600" algn="l" defTabSz="914400" rtl="0" eaLnBrk="1" latinLnBrk="0" hangingPunct="1">
+              <a:lnSpc>
+                <a:spcPct val="110000"/>
+              </a:lnSpc>
+              <a:spcBef>
+                <a:spcPts val="700"/>
+              </a:spcBef>
+              <a:buClr>
+                <a:schemeClr val="tx2"/>
+              </a:buClr>
+              <a:buFont typeface="Arial" panose="020B0604020202020204" pitchFamily="34" charset="0"/>
+              <a:buChar char="•"/>
+              <a:defRPr sz="1600" kern="1200">
+                <a:solidFill>
+                  <a:schemeClr val="tx1">
+                    <a:lumMod val="65000"/>
+                    <a:lumOff val="35000"/>
+                  </a:schemeClr>
+                </a:solidFill>
+                <a:latin typeface="+mn-lt"/>
+                <a:ea typeface="+mn-ea"/>
+                <a:cs typeface="+mn-cs"/>
+              </a:defRPr>
+            </a:lvl3pPr>
+            <a:lvl4pPr marL="1600200" indent="-228600" algn="l" defTabSz="914400" rtl="0" eaLnBrk="1" latinLnBrk="0" hangingPunct="1">
+              <a:lnSpc>
+                <a:spcPct val="110000"/>
+              </a:lnSpc>
+              <a:spcBef>
+                <a:spcPts val="700"/>
+              </a:spcBef>
+              <a:buClr>
+                <a:schemeClr val="tx2"/>
+              </a:buClr>
+              <a:buFont typeface="Gill Sans MT" panose="020B0502020104020203" pitchFamily="34" charset="0"/>
+              <a:buChar char="–"/>
+              <a:defRPr sz="1400" kern="1200">
+                <a:solidFill>
+                  <a:schemeClr val="tx1">
+                    <a:lumMod val="65000"/>
+                    <a:lumOff val="35000"/>
+                  </a:schemeClr>
+                </a:solidFill>
+                <a:latin typeface="+mn-lt"/>
+                <a:ea typeface="+mn-ea"/>
+                <a:cs typeface="+mn-cs"/>
+              </a:defRPr>
+            </a:lvl4pPr>
+            <a:lvl5pPr marL="2057400" indent="-228600" algn="l" defTabSz="914400" rtl="0" eaLnBrk="1" latinLnBrk="0" hangingPunct="1">
+              <a:lnSpc>
+                <a:spcPct val="110000"/>
+              </a:lnSpc>
+              <a:spcBef>
+                <a:spcPts val="700"/>
+              </a:spcBef>
+              <a:buClr>
+                <a:schemeClr val="tx2"/>
+              </a:buClr>
+              <a:buFont typeface="Arial" panose="020B0604020202020204" pitchFamily="34" charset="0"/>
+              <a:buChar char="•"/>
+              <a:defRPr sz="1400" kern="1200">
+                <a:solidFill>
+                  <a:schemeClr val="tx1">
+                    <a:lumMod val="65000"/>
+                    <a:lumOff val="35000"/>
+                  </a:schemeClr>
+                </a:solidFill>
+                <a:latin typeface="+mn-lt"/>
+                <a:ea typeface="+mn-ea"/>
+                <a:cs typeface="+mn-cs"/>
+              </a:defRPr>
+            </a:lvl5pPr>
+            <a:lvl6pPr marL="2514600" indent="-228600" algn="l" defTabSz="914400" rtl="0" eaLnBrk="1" latinLnBrk="0" hangingPunct="1">
+              <a:lnSpc>
+                <a:spcPct val="110000"/>
+              </a:lnSpc>
+              <a:spcBef>
+                <a:spcPts val="700"/>
+              </a:spcBef>
+              <a:buClr>
+                <a:schemeClr val="tx2"/>
+              </a:buClr>
+              <a:buFont typeface="Gill Sans MT" panose="020B0502020104020203" pitchFamily="34" charset="0"/>
+              <a:buChar char="–"/>
+              <a:defRPr sz="1400" kern="1200">
+                <a:solidFill>
+                  <a:schemeClr val="tx1">
+                    <a:lumMod val="65000"/>
+                    <a:lumOff val="35000"/>
+                  </a:schemeClr>
+                </a:solidFill>
+                <a:latin typeface="+mn-lt"/>
+                <a:ea typeface="+mn-ea"/>
+                <a:cs typeface="+mn-cs"/>
+              </a:defRPr>
+            </a:lvl6pPr>
+            <a:lvl7pPr marL="2971800" indent="-228600" algn="l" defTabSz="914400" rtl="0" eaLnBrk="1" latinLnBrk="0" hangingPunct="1">
+              <a:lnSpc>
+                <a:spcPct val="110000"/>
+              </a:lnSpc>
+              <a:spcBef>
+                <a:spcPts val="700"/>
+              </a:spcBef>
+              <a:buClr>
+                <a:schemeClr val="tx2"/>
+              </a:buClr>
+              <a:buFont typeface="Arial" panose="020B0604020202020204" pitchFamily="34" charset="0"/>
+              <a:buChar char="•"/>
+              <a:defRPr sz="1400" kern="1200">
+                <a:solidFill>
+                  <a:schemeClr val="tx1">
+                    <a:lumMod val="65000"/>
+                    <a:lumOff val="35000"/>
+                  </a:schemeClr>
+                </a:solidFill>
+                <a:latin typeface="+mn-lt"/>
+                <a:ea typeface="+mn-ea"/>
+                <a:cs typeface="+mn-cs"/>
+              </a:defRPr>
+            </a:lvl7pPr>
+            <a:lvl8pPr marL="3429000" indent="-228600" algn="l" defTabSz="914400" rtl="0" eaLnBrk="1" latinLnBrk="0" hangingPunct="1">
+              <a:lnSpc>
+                <a:spcPct val="110000"/>
+              </a:lnSpc>
+              <a:spcBef>
+                <a:spcPts val="700"/>
+              </a:spcBef>
+              <a:buClr>
+                <a:schemeClr val="tx2"/>
+              </a:buClr>
+              <a:buFont typeface="Gill Sans MT" panose="020B0502020104020203" pitchFamily="34" charset="0"/>
+              <a:buChar char="–"/>
+              <a:defRPr sz="1400" kern="1200" baseline="0">
+                <a:solidFill>
+                  <a:schemeClr val="tx1">
+                    <a:lumMod val="65000"/>
+                    <a:lumOff val="35000"/>
+                  </a:schemeClr>
+                </a:solidFill>
+                <a:latin typeface="+mn-lt"/>
+                <a:ea typeface="+mn-ea"/>
+                <a:cs typeface="+mn-cs"/>
+              </a:defRPr>
+            </a:lvl8pPr>
+            <a:lvl9pPr marL="3886200" indent="-228600" algn="l" defTabSz="914400" rtl="0" eaLnBrk="1" latinLnBrk="0" hangingPunct="1">
+              <a:lnSpc>
+                <a:spcPct val="110000"/>
+              </a:lnSpc>
+              <a:spcBef>
+                <a:spcPts val="700"/>
+              </a:spcBef>
+              <a:buClr>
+                <a:schemeClr val="tx2"/>
+              </a:buClr>
+              <a:buFont typeface="Arial" panose="020B0604020202020204" pitchFamily="34" charset="0"/>
+              <a:buChar char="•"/>
+              <a:defRPr sz="1400" kern="1200" baseline="0">
+                <a:solidFill>
+                  <a:schemeClr val="tx1">
+                    <a:lumMod val="65000"/>
+                    <a:lumOff val="35000"/>
+                  </a:schemeClr>
+                </a:solidFill>
+                <a:latin typeface="+mn-lt"/>
+                <a:ea typeface="+mn-ea"/>
+                <a:cs typeface="+mn-cs"/>
+              </a:defRPr>
+            </a:lvl9pPr>
+          </a:lstStyle>
+          <a:p>
+            <a:endParaRPr lang="en-US" dirty="0"/>
+          </a:p>
+        </p:txBody>
+      </p:sp>
+    </p:spTree>
+    <p:extLst>
+      <p:ext uri="{BB962C8B-B14F-4D97-AF65-F5344CB8AC3E}">
+        <p14:creationId xmlns:p14="http://schemas.microsoft.com/office/powerpoint/2010/main" val="50624521"/>
+      </p:ext>
+    </p:extLst>
+  </p:cSld>
+  <p:clrMapOvr>
+    <a:masterClrMapping/>
+  </p:clrMapOvr>
+</p:sld>
+</file>
+
+<file path=ppt/slides/slide8.xml><?xml version="1.0" encoding="utf-8"?>
 <p:sld xmlns:a="http://schemas.openxmlformats.org/drawingml/2006/main" xmlns:r="http://schemas.openxmlformats.org/officeDocument/2006/relationships" xmlns:p="http://schemas.openxmlformats.org/presentationml/2006/main">
   <p:cSld>
     <p:spTree>

</xml_diff>